<commit_message>
update template font size
</commit_message>
<xml_diff>
--- a/presentation/templates/pptx/plain_template.pptx
+++ b/presentation/templates/pptx/plain_template.pptx
@@ -214,7 +214,7 @@
           <a:p>
             <a:fld id="{0F9C1CCF-B725-44A7-AA57-5E433BD85C9F}" type="datetimeFigureOut">
               <a:rPr lang="en-US" smtClean="0"/>
-              <a:t>2/23/26</a:t>
+              <a:t>2/24/26</a:t>
             </a:fld>
             <a:endParaRPr lang="en-US"/>
           </a:p>
@@ -850,7 +850,7 @@
           <a:p>
             <a:fld id="{231D2103-A3C8-274D-80F3-108711FD1DDB}" type="datetime1">
               <a:rPr lang="en-US" smtClean="0"/>
-              <a:t>2/23/26</a:t>
+              <a:t>2/24/26</a:t>
             </a:fld>
             <a:endParaRPr lang="en-US"/>
           </a:p>
@@ -1018,7 +1018,7 @@
           <a:p>
             <a:fld id="{7365EA42-C278-2B40-AF87-894DFC589EFD}" type="datetime1">
               <a:rPr lang="en-US" smtClean="0"/>
-              <a:t>2/23/26</a:t>
+              <a:t>2/24/26</a:t>
             </a:fld>
             <a:endParaRPr lang="en-US"/>
           </a:p>
@@ -1196,7 +1196,7 @@
           <a:p>
             <a:fld id="{FDA60C63-0224-A147-B8C3-5898ED2FF34C}" type="datetime1">
               <a:rPr lang="en-US" smtClean="0"/>
-              <a:t>2/23/26</a:t>
+              <a:t>2/24/26</a:t>
             </a:fld>
             <a:endParaRPr lang="en-US"/>
           </a:p>
@@ -1394,7 +1394,7 @@
           <a:p>
             <a:fld id="{CA617E99-6077-1E46-9AEF-B595EE5EEB45}" type="datetime1">
               <a:rPr lang="en-US" smtClean="0"/>
-              <a:t>2/23/26</a:t>
+              <a:t>2/24/26</a:t>
             </a:fld>
             <a:endParaRPr lang="en-US"/>
           </a:p>
@@ -1639,7 +1639,7 @@
           <a:p>
             <a:fld id="{FDCFEB79-D017-B344-AADA-3FCDA11E40AC}" type="datetime1">
               <a:rPr lang="en-US" smtClean="0"/>
-              <a:t>2/23/26</a:t>
+              <a:t>2/24/26</a:t>
             </a:fld>
             <a:endParaRPr lang="en-US"/>
           </a:p>
@@ -1928,7 +1928,7 @@
           <a:p>
             <a:fld id="{FE14A905-8617-1A44-930C-8277174A5DC6}" type="datetime1">
               <a:rPr lang="en-US" smtClean="0"/>
-              <a:t>2/23/26</a:t>
+              <a:t>2/24/26</a:t>
             </a:fld>
             <a:endParaRPr lang="en-US"/>
           </a:p>
@@ -2352,7 +2352,7 @@
           <a:p>
             <a:fld id="{97FAB6E2-9383-1D43-9902-61ED3FD90156}" type="datetime1">
               <a:rPr lang="en-US" smtClean="0"/>
-              <a:t>2/23/26</a:t>
+              <a:t>2/24/26</a:t>
             </a:fld>
             <a:endParaRPr lang="en-US"/>
           </a:p>
@@ -2475,7 +2475,7 @@
           <a:p>
             <a:fld id="{1D17C6E3-F6D7-2042-BF49-2A03AC5D294E}" type="datetime1">
               <a:rPr lang="en-US" smtClean="0"/>
-              <a:t>2/23/26</a:t>
+              <a:t>2/24/26</a:t>
             </a:fld>
             <a:endParaRPr lang="en-US"/>
           </a:p>
@@ -2570,7 +2570,7 @@
           <a:p>
             <a:fld id="{395135CD-FE5A-6241-A0D5-5F8D2149AA6D}" type="datetime1">
               <a:rPr lang="en-US" smtClean="0"/>
-              <a:t>2/23/26</a:t>
+              <a:t>2/24/26</a:t>
             </a:fld>
             <a:endParaRPr lang="en-US"/>
           </a:p>
@@ -2785,7 +2785,7 @@
             <a:lvl1pPr marL="0" indent="0">
               <a:buFont typeface="Wingdings" pitchFamily="2" charset="2"/>
               <a:buChar char="v"/>
-              <a:defRPr sz="1500"/>
+              <a:defRPr sz="1400"/>
             </a:lvl1pPr>
             <a:lvl2pPr marL="342900" indent="0">
               <a:buFont typeface="Wingdings" pitchFamily="2" charset="2"/>
@@ -2857,7 +2857,7 @@
           <a:p>
             <a:fld id="{86097BBA-F049-244B-AD7E-EEBE0D5BD018}" type="datetime1">
               <a:rPr lang="en-US" smtClean="0"/>
-              <a:t>2/23/26</a:t>
+              <a:t>2/24/26</a:t>
             </a:fld>
             <a:endParaRPr lang="en-US"/>
           </a:p>
@@ -3109,7 +3109,7 @@
           <a:p>
             <a:fld id="{C8B43509-F259-4C45-9B66-8D0CAE6DF935}" type="datetime1">
               <a:rPr lang="en-US" smtClean="0"/>
-              <a:t>2/23/26</a:t>
+              <a:t>2/24/26</a:t>
             </a:fld>
             <a:endParaRPr lang="en-US"/>
           </a:p>
@@ -3320,7 +3320,7 @@
           <a:p>
             <a:fld id="{98359F6F-14C3-4744-BF6B-F86F388A0C1C}" type="datetime1">
               <a:rPr lang="en-US" smtClean="0"/>
-              <a:t>2/23/26</a:t>
+              <a:t>2/24/26</a:t>
             </a:fld>
             <a:endParaRPr lang="en-US"/>
           </a:p>

</xml_diff>